<commit_message>
feat: database and graph viewers, docs, tests and test results
- admin dbviewer and graphviewer pages (backend dbviewer.py, tests)
- updated decks, report, summary and build plan
- backend, prompt and test updates; eval check test
- latest QA results and app database snapshot

Co-Authored-By: Claude Opus 5.5 <noreply@anthropic.com>
</commit_message>
<xml_diff>
--- a/docs/XFitness-Chatbot_Presentation-v1.2.pptx
+++ b/docs/XFitness-Chatbot_Presentation-v1.2.pptx
@@ -18,6 +18,8 @@
     <p:sldId id="265" r:id="rId12"/>
     <p:sldId id="266" r:id="rId13"/>
     <p:sldId id="280" r:id="rId14"/>
+    <p:sldId id="290" r:id="rId44"/>
+    <p:sldId id="291" r:id="rId45"/>
     <p:sldId id="267" r:id="rId15"/>
     <p:sldId id="268" r:id="rId16"/>
     <p:sldId id="285" r:id="rId17"/>
@@ -7562,7 +7564,7 @@
                 <a:ea typeface="Chakra Petch"/>
                 <a:cs typeface="Chakra Petch"/>
               </a:rPr>
-              <a:t>14</a:t>
+              <a:t>16</a:t>
             </a:r>
           </a:p>
         </p:txBody>
@@ -7859,7 +7861,7 @@
                 <a:ea typeface="Chakra Petch"/>
                 <a:cs typeface="Chakra Petch"/>
               </a:rPr>
-              <a:t>15</a:t>
+              <a:t>17</a:t>
             </a:r>
           </a:p>
         </p:txBody>
@@ -8172,7 +8174,7 @@
                 <a:ea typeface="Chakra Petch"/>
                 <a:cs typeface="Chakra Petch"/>
               </a:rPr>
-              <a:t>16</a:t>
+              <a:t>18</a:t>
             </a:r>
           </a:p>
         </p:txBody>
@@ -9960,7 +9962,7 @@
                 <a:ea typeface="Chakra Petch"/>
                 <a:cs typeface="Chakra Petch"/>
               </a:rPr>
-              <a:t>17</a:t>
+              <a:t>19</a:t>
             </a:r>
           </a:p>
         </p:txBody>
@@ -11313,7 +11315,7 @@
                 <a:ea typeface="Chakra Petch"/>
                 <a:cs typeface="Chakra Petch"/>
               </a:rPr>
-              <a:t>18</a:t>
+              <a:t>20</a:t>
             </a:r>
           </a:p>
         </p:txBody>
@@ -11626,7 +11628,7 @@
                 <a:ea typeface="Chakra Petch"/>
                 <a:cs typeface="Chakra Petch"/>
               </a:rPr>
-              <a:t>19</a:t>
+              <a:t>21</a:t>
             </a:r>
           </a:p>
         </p:txBody>
@@ -12966,7 +12968,7 @@
                 <a:ea typeface="Chakra Petch"/>
                 <a:cs typeface="Chakra Petch"/>
               </a:rPr>
-              <a:t>02</a:t>
+              <a:t>2</a:t>
             </a:r>
           </a:p>
         </p:txBody>
@@ -13797,7 +13799,7 @@
                 <a:ea typeface="Chakra Petch"/>
                 <a:cs typeface="Chakra Petch"/>
               </a:rPr>
-              <a:t>20</a:t>
+              <a:t>22</a:t>
             </a:r>
           </a:p>
         </p:txBody>
@@ -14110,7 +14112,7 @@
                 <a:ea typeface="Chakra Petch"/>
                 <a:cs typeface="Chakra Petch"/>
               </a:rPr>
-              <a:t>21</a:t>
+              <a:t>23</a:t>
             </a:r>
           </a:p>
         </p:txBody>
@@ -15442,7 +15444,7 @@
                 <a:ea typeface="Chakra Petch"/>
                 <a:cs typeface="Chakra Petch"/>
               </a:rPr>
-              <a:t>22</a:t>
+              <a:t>24</a:t>
             </a:r>
           </a:p>
         </p:txBody>
@@ -15755,7 +15757,7 @@
                 <a:ea typeface="Chakra Petch"/>
                 <a:cs typeface="Chakra Petch"/>
               </a:rPr>
-              <a:t>23</a:t>
+              <a:t>25</a:t>
             </a:r>
           </a:p>
         </p:txBody>
@@ -17988,7 +17990,7 @@
                 <a:ea typeface="Chakra Petch"/>
                 <a:cs typeface="Chakra Petch"/>
               </a:rPr>
-              <a:t>24</a:t>
+              <a:t>26</a:t>
             </a:r>
           </a:p>
         </p:txBody>
@@ -18301,7 +18303,7 @@
                 <a:ea typeface="Chakra Petch"/>
                 <a:cs typeface="Chakra Petch"/>
               </a:rPr>
-              <a:t>25</a:t>
+              <a:t>27</a:t>
             </a:r>
           </a:p>
         </p:txBody>
@@ -20142,7 +20144,7 @@
                 <a:ea typeface="Chakra Petch"/>
                 <a:cs typeface="Chakra Petch"/>
               </a:rPr>
-              <a:t>26</a:t>
+              <a:t>28</a:t>
             </a:r>
           </a:p>
         </p:txBody>
@@ -20455,7 +20457,7 @@
                 <a:ea typeface="Chakra Petch"/>
                 <a:cs typeface="Chakra Petch"/>
               </a:rPr>
-              <a:t>27</a:t>
+              <a:t>29</a:t>
             </a:r>
           </a:p>
         </p:txBody>
@@ -21111,7 +21113,7 @@
                 <a:ea typeface="Chakra Petch"/>
                 <a:cs typeface="Chakra Petch"/>
               </a:rPr>
-              <a:t>28</a:t>
+              <a:t>30</a:t>
             </a:r>
           </a:p>
         </p:txBody>
@@ -22339,7 +22341,7 @@
                 <a:ea typeface="Chakra Petch"/>
                 <a:cs typeface="Chakra Petch"/>
               </a:rPr>
-              <a:t>29</a:t>
+              <a:t>31</a:t>
             </a:r>
           </a:p>
         </p:txBody>
@@ -22688,7 +22690,7 @@
                 <a:ea typeface="Chakra Petch"/>
                 <a:cs typeface="Chakra Petch"/>
               </a:rPr>
-              <a:t>03</a:t>
+              <a:t>3</a:t>
             </a:r>
           </a:p>
         </p:txBody>
@@ -23021,7 +23023,7 @@
                 <a:ea typeface="Chakra Petch"/>
                 <a:cs typeface="Chakra Petch"/>
               </a:rPr>
-              <a:t>30</a:t>
+              <a:t>32</a:t>
             </a:r>
           </a:p>
         </p:txBody>
@@ -24198,7 +24200,7 @@
                 <a:ea typeface="Chakra Petch"/>
                 <a:cs typeface="Chakra Petch"/>
               </a:rPr>
-              <a:t>31</a:t>
+              <a:t>33</a:t>
             </a:r>
           </a:p>
         </p:txBody>
@@ -24795,7 +24797,7 @@
                 <a:ea typeface="Chakra Petch"/>
                 <a:cs typeface="Chakra Petch"/>
               </a:rPr>
-              <a:t>32</a:t>
+              <a:t>34</a:t>
             </a:r>
           </a:p>
         </p:txBody>
@@ -25393,7 +25395,7 @@
                 <a:ea typeface="Chakra Petch"/>
                 <a:cs typeface="Chakra Petch"/>
               </a:rPr>
-              <a:t>33</a:t>
+              <a:t>35</a:t>
             </a:r>
           </a:p>
         </p:txBody>
@@ -26457,11 +26459,2245 @@
                 <a:ea typeface="Chakra Petch"/>
                 <a:cs typeface="Chakra Petch"/>
               </a:rPr>
-              <a:t>34</a:t>
-            </a:r>
-          </a:p>
-        </p:txBody>
-      </p:sp>
+              <a:t>36</a:t>
+            </a:r>
+          </a:p>
+        </p:txBody>
+      </p:sp>
+    </p:spTree>
+  </p:cSld>
+  <p:clrMapOvr>
+    <a:masterClrMapping/>
+  </p:clrMapOvr>
+</p:sld>
+</file>
+
+<file path=ppt/slides/slide35.xml><?xml version="1.0" encoding="utf-8"?>
+<p:sld xmlns:a="http://schemas.openxmlformats.org/drawingml/2006/main" xmlns:p="http://schemas.openxmlformats.org/presentationml/2006/main" xmlns:r="http://schemas.openxmlformats.org/officeDocument/2006/relationships">
+  <p:cSld>
+    <p:bg>
+      <p:bgPr>
+        <a:solidFill>
+          <a:srgbClr val="09090A"/>
+        </a:solidFill>
+        <a:effectLst/>
+      </p:bgPr>
+    </p:bg>
+    <p:spTree>
+      <p:nvGrpSpPr>
+        <p:cNvPr id="1" name=""/>
+        <p:cNvGrpSpPr/>
+        <p:nvPr/>
+      </p:nvGrpSpPr>
+      <p:grpSpPr/>
+      <p:sp>
+        <p:nvSpPr>
+          <p:cNvPr id="2" name="Rectangle 1"/>
+          <p:cNvSpPr/>
+          <p:nvPr/>
+        </p:nvSpPr>
+        <p:spPr>
+          <a:xfrm>
+            <a:off x="612648" y="566928"/>
+            <a:ext cx="109728" cy="109728"/>
+          </a:xfrm>
+          <a:prstGeom prst="rect">
+            <a:avLst/>
+          </a:prstGeom>
+          <a:solidFill>
+            <a:srgbClr val="E10613"/>
+          </a:solidFill>
+          <a:ln>
+            <a:noFill/>
+          </a:ln>
+          <a:effectLst/>
+        </p:spPr>
+        <p:style>
+          <a:lnRef idx="1">
+            <a:schemeClr val="accent1"/>
+          </a:lnRef>
+          <a:fillRef idx="3">
+            <a:schemeClr val="accent1"/>
+          </a:fillRef>
+          <a:effectRef idx="2">
+            <a:schemeClr val="accent1"/>
+          </a:effectRef>
+          <a:fontRef idx="minor">
+            <a:schemeClr val="lt1"/>
+          </a:fontRef>
+        </p:style>
+        <p:txBody>
+          <a:bodyPr rtlCol="0" anchor="ctr"/>
+          <a:lstStyle/>
+          <a:p>
+            <a:pPr algn="ctr"/>
+            <a:endParaRPr/>
+          </a:p>
+        </p:txBody>
+      </p:sp>
+      <p:sp>
+        <p:nvSpPr>
+          <p:cNvPr id="3" name="TextBox 2"/>
+          <p:cNvSpPr txBox="1"/>
+          <p:nvPr/>
+        </p:nvSpPr>
+        <p:spPr>
+          <a:xfrm>
+            <a:off x="832104" y="475488"/>
+            <a:ext cx="7315200" cy="274320"/>
+          </a:xfrm>
+          <a:prstGeom prst="rect">
+            <a:avLst/>
+          </a:prstGeom>
+          <a:noFill/>
+        </p:spPr>
+        <p:txBody>
+          <a:bodyPr wrap="square" lIns="0" tIns="0" rIns="0" bIns="0" anchor="t">
+            <a:spAutoFit/>
+          </a:bodyPr>
+          <a:lstStyle/>
+          <a:p>
+            <a:pPr algn="l">
+              <a:lnSpc>
+                <a:spcPct val="100000"/>
+              </a:lnSpc>
+              <a:spcAft>
+                <a:spcPts val="0"/>
+              </a:spcAft>
+            </a:pPr>
+            <a:r>
+              <a:rPr sz="1200" b="1">
+                <a:solidFill>
+                  <a:srgbClr val="A3A3A8"/>
+                </a:solidFill>
+                <a:latin typeface="Chakra Petch"/>
+                <a:ea typeface="Chakra Petch"/>
+                <a:cs typeface="Chakra Petch"/>
+              </a:rPr>
+              <a:t>องค์ประกอบของระบบ</a:t>
+            </a:r>
+          </a:p>
+        </p:txBody>
+      </p:sp>
+      <p:sp>
+        <p:nvSpPr>
+          <p:cNvPr id="4" name="TextBox 3"/>
+          <p:cNvSpPr txBox="1"/>
+          <p:nvPr/>
+        </p:nvSpPr>
+        <p:spPr>
+          <a:xfrm>
+            <a:off x="612648" y="841248"/>
+            <a:ext cx="10966399" cy="822960"/>
+          </a:xfrm>
+          <a:prstGeom prst="rect">
+            <a:avLst/>
+          </a:prstGeom>
+          <a:noFill/>
+        </p:spPr>
+        <p:txBody>
+          <a:bodyPr wrap="square" lIns="0" tIns="0" rIns="0" bIns="0" anchor="t">
+            <a:spAutoFit/>
+          </a:bodyPr>
+          <a:lstStyle/>
+          <a:p>
+            <a:pPr algn="l">
+              <a:lnSpc>
+                <a:spcPct val="115000"/>
+              </a:lnSpc>
+              <a:spcAft>
+                <a:spcPts val="0"/>
+              </a:spcAft>
+            </a:pPr>
+            <a:r>
+              <a:rPr sz="2800" b="1">
+                <a:solidFill>
+                  <a:srgbClr val="F5F5F4"/>
+                </a:solidFill>
+                <a:latin typeface="Chakra Petch"/>
+                <a:ea typeface="Chakra Petch"/>
+                <a:cs typeface="Chakra Petch"/>
+              </a:rPr>
+              <a:t>ข้อมูลร้านและแชตอยู่ใน SQLite ไฟล์เดียว 176 KB build ไว้ก่อน commit</a:t>
+            </a:r>
+          </a:p>
+        </p:txBody>
+      </p:sp>
+      <p:cxnSp>
+        <p:nvCxnSpPr>
+          <p:cNvPr id="5" name="Connector 4"/>
+          <p:cNvCxnSpPr/>
+          <p:nvPr/>
+        </p:nvCxnSpPr>
+        <p:spPr>
+          <a:xfrm>
+            <a:off x="612648" y="6291072"/>
+            <a:ext cx="10966399" cy="0"/>
+          </a:xfrm>
+          <a:prstGeom prst="line">
+            <a:avLst/>
+          </a:prstGeom>
+          <a:ln w="9525">
+            <a:solidFill>
+              <a:srgbClr val="26262B"/>
+            </a:solidFill>
+          </a:ln>
+        </p:spPr>
+        <p:style>
+          <a:lnRef idx="2">
+            <a:schemeClr val="accent1"/>
+          </a:lnRef>
+          <a:fillRef idx="0">
+            <a:schemeClr val="accent1"/>
+          </a:fillRef>
+          <a:effectRef idx="1">
+            <a:schemeClr val="accent1"/>
+          </a:effectRef>
+          <a:fontRef idx="minor">
+            <a:schemeClr val="tx1"/>
+          </a:fontRef>
+        </p:style>
+      </p:cxnSp>
+      <p:sp>
+        <p:nvSpPr>
+          <p:cNvPr id="6" name="TextBox 5"/>
+          <p:cNvSpPr txBox="1"/>
+          <p:nvPr/>
+        </p:nvSpPr>
+        <p:spPr>
+          <a:xfrm>
+            <a:off x="612648" y="6400800"/>
+            <a:ext cx="7315200" cy="274320"/>
+          </a:xfrm>
+          <a:prstGeom prst="rect">
+            <a:avLst/>
+          </a:prstGeom>
+          <a:noFill/>
+        </p:spPr>
+        <p:txBody>
+          <a:bodyPr wrap="square" lIns="0" tIns="0" rIns="0" bIns="0" anchor="t">
+            <a:spAutoFit/>
+          </a:bodyPr>
+          <a:lstStyle/>
+          <a:p>
+            <a:pPr algn="l">
+              <a:lnSpc>
+                <a:spcPct val="100000"/>
+              </a:lnSpc>
+              <a:spcAft>
+                <a:spcPts val="0"/>
+              </a:spcAft>
+            </a:pPr>
+            <a:r>
+              <a:rPr sz="1100" b="0">
+                <a:solidFill>
+                  <a:srgbClr val="6B6B72"/>
+                </a:solidFill>
+                <a:latin typeface="Chakra Petch"/>
+                <a:ea typeface="Chakra Petch"/>
+                <a:cs typeface="Chakra Petch"/>
+              </a:rPr>
+              <a:t>X FITNESS CHATBOT   ·   องค์ประกอบของระบบ</a:t>
+            </a:r>
+          </a:p>
+        </p:txBody>
+      </p:sp>
+      <p:sp>
+        <p:nvSpPr>
+          <p:cNvPr id="7" name="TextBox 6"/>
+          <p:cNvSpPr txBox="1"/>
+          <p:nvPr/>
+        </p:nvSpPr>
+        <p:spPr>
+          <a:xfrm>
+            <a:off x="10664647" y="6400800"/>
+            <a:ext cx="914400" cy="274320"/>
+          </a:xfrm>
+          <a:prstGeom prst="rect">
+            <a:avLst/>
+          </a:prstGeom>
+          <a:noFill/>
+        </p:spPr>
+        <p:txBody>
+          <a:bodyPr wrap="square" lIns="0" tIns="0" rIns="0" bIns="0" anchor="t">
+            <a:spAutoFit/>
+          </a:bodyPr>
+          <a:lstStyle/>
+          <a:p>
+            <a:pPr algn="r">
+              <a:lnSpc>
+                <a:spcPct val="100000"/>
+              </a:lnSpc>
+              <a:spcAft>
+                <a:spcPts val="0"/>
+              </a:spcAft>
+            </a:pPr>
+            <a:r>
+              <a:rPr sz="1100" b="0">
+                <a:solidFill>
+                  <a:srgbClr val="A3A3A8"/>
+                </a:solidFill>
+                <a:latin typeface="Chakra Petch"/>
+                <a:ea typeface="Chakra Petch"/>
+                <a:cs typeface="Chakra Petch"/>
+              </a:rPr>
+              <a:t>14</a:t>
+            </a:r>
+          </a:p>
+        </p:txBody>
+      </p:sp>
+      <p:sp>
+        <p:nvSpPr>
+          <p:cNvPr id="8" name="TextBox 7"/>
+          <p:cNvSpPr txBox="1"/>
+          <p:nvPr/>
+        </p:nvSpPr>
+        <p:spPr>
+          <a:xfrm>
+            <a:off x="612648" y="1874519"/>
+            <a:ext cx="2194560" cy="274320"/>
+          </a:xfrm>
+          <a:prstGeom prst="rect">
+            <a:avLst/>
+          </a:prstGeom>
+          <a:noFill/>
+        </p:spPr>
+        <p:txBody>
+          <a:bodyPr wrap="square" lIns="0" tIns="0" rIns="0" bIns="0" anchor="t">
+            <a:spAutoFit/>
+          </a:bodyPr>
+          <a:lstStyle/>
+          <a:p>
+            <a:pPr algn="l">
+              <a:lnSpc>
+                <a:spcPct val="100000"/>
+              </a:lnSpc>
+              <a:spcAft>
+                <a:spcPts val="0"/>
+              </a:spcAft>
+            </a:pPr>
+            <a:r>
+              <a:rPr sz="1200" b="1">
+                <a:solidFill>
+                  <a:srgbClr val="6B6B72"/>
+                </a:solidFill>
+                <a:latin typeface="Chakra Petch"/>
+                <a:ea typeface="Chakra Petch"/>
+                <a:cs typeface="Chakra Petch"/>
+              </a:rPr>
+              <a:t>กลุ่ม</a:t>
+            </a:r>
+          </a:p>
+        </p:txBody>
+      </p:sp>
+      <p:sp>
+        <p:nvSpPr>
+          <p:cNvPr id="9" name="TextBox 8"/>
+          <p:cNvSpPr txBox="1"/>
+          <p:nvPr/>
+        </p:nvSpPr>
+        <p:spPr>
+          <a:xfrm>
+            <a:off x="2990088" y="1874519"/>
+            <a:ext cx="4023359" cy="274320"/>
+          </a:xfrm>
+          <a:prstGeom prst="rect">
+            <a:avLst/>
+          </a:prstGeom>
+          <a:noFill/>
+        </p:spPr>
+        <p:txBody>
+          <a:bodyPr wrap="square" lIns="0" tIns="0" rIns="0" bIns="0" anchor="t">
+            <a:spAutoFit/>
+          </a:bodyPr>
+          <a:lstStyle/>
+          <a:p>
+            <a:pPr algn="l">
+              <a:lnSpc>
+                <a:spcPct val="100000"/>
+              </a:lnSpc>
+              <a:spcAft>
+                <a:spcPts val="0"/>
+              </a:spcAft>
+            </a:pPr>
+            <a:r>
+              <a:rPr sz="1200" b="1">
+                <a:solidFill>
+                  <a:srgbClr val="6B6B72"/>
+                </a:solidFill>
+                <a:latin typeface="Chakra Petch"/>
+                <a:ea typeface="Chakra Petch"/>
+                <a:cs typeface="Chakra Petch"/>
+              </a:rPr>
+              <a:t>เก็บอะไร</a:t>
+            </a:r>
+          </a:p>
+        </p:txBody>
+      </p:sp>
+      <p:sp>
+        <p:nvSpPr>
+          <p:cNvPr id="10" name="TextBox 9"/>
+          <p:cNvSpPr txBox="1"/>
+          <p:nvPr/>
+        </p:nvSpPr>
+        <p:spPr>
+          <a:xfrm>
+            <a:off x="7196327" y="1874519"/>
+            <a:ext cx="4199839" cy="274320"/>
+          </a:xfrm>
+          <a:prstGeom prst="rect">
+            <a:avLst/>
+          </a:prstGeom>
+          <a:noFill/>
+        </p:spPr>
+        <p:txBody>
+          <a:bodyPr wrap="square" lIns="0" tIns="0" rIns="0" bIns="0" anchor="t">
+            <a:spAutoFit/>
+          </a:bodyPr>
+          <a:lstStyle/>
+          <a:p>
+            <a:pPr algn="l">
+              <a:lnSpc>
+                <a:spcPct val="100000"/>
+              </a:lnSpc>
+              <a:spcAft>
+                <a:spcPts val="0"/>
+              </a:spcAft>
+            </a:pPr>
+            <a:r>
+              <a:rPr sz="1200" b="1">
+                <a:solidFill>
+                  <a:srgbClr val="6B6B72"/>
+                </a:solidFill>
+                <a:latin typeface="Chakra Petch"/>
+                <a:ea typeface="Chakra Petch"/>
+                <a:cs typeface="Chakra Petch"/>
+              </a:rPr>
+              <a:t>ตัวอย่าง</a:t>
+            </a:r>
+          </a:p>
+        </p:txBody>
+      </p:sp>
+      <p:cxnSp>
+        <p:nvCxnSpPr>
+          <p:cNvPr id="11" name="Connector 10"/>
+          <p:cNvCxnSpPr/>
+          <p:nvPr/>
+        </p:nvCxnSpPr>
+        <p:spPr>
+          <a:xfrm>
+            <a:off x="612648" y="2258568"/>
+            <a:ext cx="10966399" cy="0"/>
+          </a:xfrm>
+          <a:prstGeom prst="line">
+            <a:avLst/>
+          </a:prstGeom>
+          <a:ln w="9525">
+            <a:solidFill>
+              <a:srgbClr val="34343C"/>
+            </a:solidFill>
+          </a:ln>
+        </p:spPr>
+        <p:style>
+          <a:lnRef idx="2">
+            <a:schemeClr val="accent1"/>
+          </a:lnRef>
+          <a:fillRef idx="0">
+            <a:schemeClr val="accent1"/>
+          </a:fillRef>
+          <a:effectRef idx="1">
+            <a:schemeClr val="accent1"/>
+          </a:effectRef>
+          <a:fontRef idx="minor">
+            <a:schemeClr val="tx1"/>
+          </a:fontRef>
+        </p:style>
+      </p:cxnSp>
+      <p:sp>
+        <p:nvSpPr>
+          <p:cNvPr id="12" name="TextBox 11"/>
+          <p:cNvSpPr txBox="1"/>
+          <p:nvPr/>
+        </p:nvSpPr>
+        <p:spPr>
+          <a:xfrm>
+            <a:off x="612648" y="2404872"/>
+            <a:ext cx="2148840" cy="630936"/>
+          </a:xfrm>
+          <a:prstGeom prst="rect">
+            <a:avLst/>
+          </a:prstGeom>
+          <a:noFill/>
+        </p:spPr>
+        <p:txBody>
+          <a:bodyPr wrap="square" lIns="0" tIns="0" rIns="0" bIns="0" anchor="t">
+            <a:spAutoFit/>
+          </a:bodyPr>
+          <a:lstStyle/>
+          <a:p>
+            <a:pPr algn="l">
+              <a:lnSpc>
+                <a:spcPct val="135000"/>
+              </a:lnSpc>
+              <a:spcAft>
+                <a:spcPts val="0"/>
+              </a:spcAft>
+            </a:pPr>
+            <a:r>
+              <a:rPr sz="1700" b="0">
+                <a:solidFill>
+                  <a:srgbClr val="A3A3A8"/>
+                </a:solidFill>
+                <a:latin typeface="IBM Plex Sans Thai"/>
+                <a:ea typeface="IBM Plex Sans Thai"/>
+                <a:cs typeface="IBM Plex Sans Thai"/>
+              </a:rPr>
+              <a:t>ข้อมูลร้าน · 12 ตาราง</a:t>
+            </a:r>
+          </a:p>
+        </p:txBody>
+      </p:sp>
+      <p:sp>
+        <p:nvSpPr>
+          <p:cNvPr id="13" name="TextBox 12"/>
+          <p:cNvSpPr txBox="1"/>
+          <p:nvPr/>
+        </p:nvSpPr>
+        <p:spPr>
+          <a:xfrm>
+            <a:off x="2990088" y="2404872"/>
+            <a:ext cx="3977639" cy="630936"/>
+          </a:xfrm>
+          <a:prstGeom prst="rect">
+            <a:avLst/>
+          </a:prstGeom>
+          <a:noFill/>
+        </p:spPr>
+        <p:txBody>
+          <a:bodyPr wrap="square" lIns="0" tIns="0" rIns="0" bIns="0" anchor="t">
+            <a:spAutoFit/>
+          </a:bodyPr>
+          <a:lstStyle/>
+          <a:p>
+            <a:pPr algn="l">
+              <a:lnSpc>
+                <a:spcPct val="135000"/>
+              </a:lnSpc>
+              <a:spcAft>
+                <a:spcPts val="0"/>
+              </a:spcAft>
+            </a:pPr>
+            <a:r>
+              <a:rPr sz="2000" b="1">
+                <a:solidFill>
+                  <a:srgbClr val="F5F5F4"/>
+                </a:solidFill>
+                <a:latin typeface="IBM Plex Sans Thai"/>
+                <a:ea typeface="IBM Plex Sans Thai"/>
+                <a:cs typeface="IBM Plex Sans Thai"/>
+              </a:rPr>
+              <a:t>แพ็กเกจ คลาส สมาชิก ยอดชำระ</a:t>
+            </a:r>
+          </a:p>
+        </p:txBody>
+      </p:sp>
+      <p:sp>
+        <p:nvSpPr>
+          <p:cNvPr id="14" name="TextBox 13"/>
+          <p:cNvSpPr txBox="1"/>
+          <p:nvPr/>
+        </p:nvSpPr>
+        <p:spPr>
+          <a:xfrm>
+            <a:off x="7196327" y="2404872"/>
+            <a:ext cx="4154119" cy="630936"/>
+          </a:xfrm>
+          <a:prstGeom prst="rect">
+            <a:avLst/>
+          </a:prstGeom>
+          <a:noFill/>
+        </p:spPr>
+        <p:txBody>
+          <a:bodyPr wrap="square" lIns="0" tIns="0" rIns="0" bIns="0" anchor="t">
+            <a:spAutoFit/>
+          </a:bodyPr>
+          <a:lstStyle/>
+          <a:p>
+            <a:pPr algn="l">
+              <a:lnSpc>
+                <a:spcPct val="135000"/>
+              </a:lnSpc>
+              <a:spcAft>
+                <a:spcPts val="0"/>
+              </a:spcAft>
+            </a:pPr>
+            <a:r>
+              <a:rPr sz="1800" b="0">
+                <a:solidFill>
+                  <a:srgbClr val="D4D4D8"/>
+                </a:solidFill>
+                <a:latin typeface="IBM Plex Sans Thai"/>
+                <a:ea typeface="IBM Plex Sans Thai"/>
+                <a:cs typeface="IBM Plex Sans Thai"/>
+              </a:rPr>
+              <a:t>members: FN-10001 · 1,240 แต้ม</a:t>
+            </a:r>
+          </a:p>
+        </p:txBody>
+      </p:sp>
+      <p:cxnSp>
+        <p:nvCxnSpPr>
+          <p:cNvPr id="15" name="Connector 14"/>
+          <p:cNvCxnSpPr/>
+          <p:nvPr/>
+        </p:nvCxnSpPr>
+        <p:spPr>
+          <a:xfrm>
+            <a:off x="612648" y="3035808"/>
+            <a:ext cx="10966399" cy="0"/>
+          </a:xfrm>
+          <a:prstGeom prst="line">
+            <a:avLst/>
+          </a:prstGeom>
+          <a:ln w="9525">
+            <a:solidFill>
+              <a:srgbClr val="26262B"/>
+            </a:solidFill>
+          </a:ln>
+        </p:spPr>
+        <p:style>
+          <a:lnRef idx="2">
+            <a:schemeClr val="accent1"/>
+          </a:lnRef>
+          <a:fillRef idx="0">
+            <a:schemeClr val="accent1"/>
+          </a:fillRef>
+          <a:effectRef idx="1">
+            <a:schemeClr val="accent1"/>
+          </a:effectRef>
+          <a:fontRef idx="minor">
+            <a:schemeClr val="tx1"/>
+          </a:fontRef>
+        </p:style>
+      </p:cxnSp>
+      <p:sp>
+        <p:nvSpPr>
+          <p:cNvPr id="16" name="TextBox 15"/>
+          <p:cNvSpPr txBox="1"/>
+          <p:nvPr/>
+        </p:nvSpPr>
+        <p:spPr>
+          <a:xfrm>
+            <a:off x="612648" y="3182112"/>
+            <a:ext cx="2148840" cy="630936"/>
+          </a:xfrm>
+          <a:prstGeom prst="rect">
+            <a:avLst/>
+          </a:prstGeom>
+          <a:noFill/>
+        </p:spPr>
+        <p:txBody>
+          <a:bodyPr wrap="square" lIns="0" tIns="0" rIns="0" bIns="0" anchor="t">
+            <a:spAutoFit/>
+          </a:bodyPr>
+          <a:lstStyle/>
+          <a:p>
+            <a:pPr algn="l">
+              <a:lnSpc>
+                <a:spcPct val="135000"/>
+              </a:lnSpc>
+              <a:spcAft>
+                <a:spcPts val="0"/>
+              </a:spcAft>
+            </a:pPr>
+            <a:r>
+              <a:rPr sz="1700" b="0">
+                <a:solidFill>
+                  <a:srgbClr val="A3A3A8"/>
+                </a:solidFill>
+                <a:latin typeface="IBM Plex Sans Thai"/>
+                <a:ea typeface="IBM Plex Sans Thai"/>
+                <a:cs typeface="IBM Plex Sans Thai"/>
+              </a:rPr>
+              <a:t>แชต · 5 ตาราง</a:t>
+            </a:r>
+          </a:p>
+        </p:txBody>
+      </p:sp>
+      <p:sp>
+        <p:nvSpPr>
+          <p:cNvPr id="17" name="TextBox 16"/>
+          <p:cNvSpPr txBox="1"/>
+          <p:nvPr/>
+        </p:nvSpPr>
+        <p:spPr>
+          <a:xfrm>
+            <a:off x="2990088" y="3182112"/>
+            <a:ext cx="3977639" cy="630936"/>
+          </a:xfrm>
+          <a:prstGeom prst="rect">
+            <a:avLst/>
+          </a:prstGeom>
+          <a:noFill/>
+        </p:spPr>
+        <p:txBody>
+          <a:bodyPr wrap="square" lIns="0" tIns="0" rIns="0" bIns="0" anchor="t">
+            <a:spAutoFit/>
+          </a:bodyPr>
+          <a:lstStyle/>
+          <a:p>
+            <a:pPr algn="l">
+              <a:lnSpc>
+                <a:spcPct val="135000"/>
+              </a:lnSpc>
+              <a:spcAft>
+                <a:spcPts val="0"/>
+              </a:spcAft>
+            </a:pPr>
+            <a:r>
+              <a:rPr sz="2000" b="1">
+                <a:solidFill>
+                  <a:srgbClr val="F5F5F4"/>
+                </a:solidFill>
+                <a:latin typeface="IBM Plex Sans Thai"/>
+                <a:ea typeface="IBM Plex Sans Thai"/>
+                <a:cs typeface="IBM Plex Sans Thai"/>
+              </a:rPr>
+              <a:t>ห้องแชต ข้อความ สลิป LINE</a:t>
+            </a:r>
+          </a:p>
+        </p:txBody>
+      </p:sp>
+      <p:sp>
+        <p:nvSpPr>
+          <p:cNvPr id="18" name="TextBox 17"/>
+          <p:cNvSpPr txBox="1"/>
+          <p:nvPr/>
+        </p:nvSpPr>
+        <p:spPr>
+          <a:xfrm>
+            <a:off x="7196327" y="3182112"/>
+            <a:ext cx="4154119" cy="630936"/>
+          </a:xfrm>
+          <a:prstGeom prst="rect">
+            <a:avLst/>
+          </a:prstGeom>
+          <a:noFill/>
+        </p:spPr>
+        <p:txBody>
+          <a:bodyPr wrap="square" lIns="0" tIns="0" rIns="0" bIns="0" anchor="t">
+            <a:spAutoFit/>
+          </a:bodyPr>
+          <a:lstStyle/>
+          <a:p>
+            <a:pPr algn="l">
+              <a:lnSpc>
+                <a:spcPct val="135000"/>
+              </a:lnSpc>
+              <a:spcAft>
+                <a:spcPts val="0"/>
+              </a:spcAft>
+            </a:pPr>
+            <a:r>
+              <a:rPr sz="1800" b="0">
+                <a:solidFill>
+                  <a:srgbClr val="D4D4D8"/>
+                </a:solidFill>
+                <a:latin typeface="IBM Plex Sans Thai"/>
+                <a:ea typeface="IBM Plex Sans Thai"/>
+                <a:cs typeface="IBM Plex Sans Thai"/>
+              </a:rPr>
+              <a:t>messages: user → "วันเสาร์เปิดกี่โมง"</a:t>
+            </a:r>
+          </a:p>
+        </p:txBody>
+      </p:sp>
+      <p:cxnSp>
+        <p:nvCxnSpPr>
+          <p:cNvPr id="19" name="Connector 18"/>
+          <p:cNvCxnSpPr/>
+          <p:nvPr/>
+        </p:nvCxnSpPr>
+        <p:spPr>
+          <a:xfrm>
+            <a:off x="612648" y="3813048"/>
+            <a:ext cx="10966399" cy="0"/>
+          </a:xfrm>
+          <a:prstGeom prst="line">
+            <a:avLst/>
+          </a:prstGeom>
+          <a:ln w="9525">
+            <a:solidFill>
+              <a:srgbClr val="26262B"/>
+            </a:solidFill>
+          </a:ln>
+        </p:spPr>
+        <p:style>
+          <a:lnRef idx="2">
+            <a:schemeClr val="accent1"/>
+          </a:lnRef>
+          <a:fillRef idx="0">
+            <a:schemeClr val="accent1"/>
+          </a:fillRef>
+          <a:effectRef idx="1">
+            <a:schemeClr val="accent1"/>
+          </a:effectRef>
+          <a:fontRef idx="minor">
+            <a:schemeClr val="tx1"/>
+          </a:fontRef>
+        </p:style>
+      </p:cxnSp>
+      <p:sp>
+        <p:nvSpPr>
+          <p:cNvPr id="20" name="TextBox 19"/>
+          <p:cNvSpPr txBox="1"/>
+          <p:nvPr/>
+        </p:nvSpPr>
+        <p:spPr>
+          <a:xfrm>
+            <a:off x="612648" y="3959352"/>
+            <a:ext cx="2148840" cy="630936"/>
+          </a:xfrm>
+          <a:prstGeom prst="rect">
+            <a:avLst/>
+          </a:prstGeom>
+          <a:noFill/>
+        </p:spPr>
+        <p:txBody>
+          <a:bodyPr wrap="square" lIns="0" tIns="0" rIns="0" bIns="0" anchor="t">
+            <a:spAutoFit/>
+          </a:bodyPr>
+          <a:lstStyle/>
+          <a:p>
+            <a:pPr algn="l">
+              <a:lnSpc>
+                <a:spcPct val="135000"/>
+              </a:lnSpc>
+              <a:spcAft>
+                <a:spcPts val="0"/>
+              </a:spcAft>
+            </a:pPr>
+            <a:r>
+              <a:rPr sz="1700" b="0">
+                <a:solidFill>
+                  <a:srgbClr val="A3A3A8"/>
+                </a:solidFill>
+                <a:latin typeface="IBM Plex Sans Thai"/>
+                <a:ea typeface="IBM Plex Sans Thai"/>
+                <a:cs typeface="IBM Plex Sans Thai"/>
+              </a:rPr>
+              <a:t>ระบบ · 2 ตาราง</a:t>
+            </a:r>
+          </a:p>
+        </p:txBody>
+      </p:sp>
+      <p:sp>
+        <p:nvSpPr>
+          <p:cNvPr id="21" name="TextBox 20"/>
+          <p:cNvSpPr txBox="1"/>
+          <p:nvPr/>
+        </p:nvSpPr>
+        <p:spPr>
+          <a:xfrm>
+            <a:off x="2990088" y="3959352"/>
+            <a:ext cx="3977639" cy="630936"/>
+          </a:xfrm>
+          <a:prstGeom prst="rect">
+            <a:avLst/>
+          </a:prstGeom>
+          <a:noFill/>
+        </p:spPr>
+        <p:txBody>
+          <a:bodyPr wrap="square" lIns="0" tIns="0" rIns="0" bIns="0" anchor="t">
+            <a:spAutoFit/>
+          </a:bodyPr>
+          <a:lstStyle/>
+          <a:p>
+            <a:pPr algn="l">
+              <a:lnSpc>
+                <a:spcPct val="135000"/>
+              </a:lnSpc>
+              <a:spcAft>
+                <a:spcPts val="0"/>
+              </a:spcAft>
+            </a:pPr>
+            <a:r>
+              <a:rPr sz="2000" b="1">
+                <a:solidFill>
+                  <a:srgbClr val="F5F5F4"/>
+                </a:solidFill>
+                <a:latin typeface="IBM Plex Sans Thai"/>
+                <a:ea typeface="IBM Plex Sans Thai"/>
+                <a:cs typeface="IBM Plex Sans Thai"/>
+              </a:rPr>
+              <a:t>ค่าตั้งต้นของร้าน กติกาแต้ม</a:t>
+            </a:r>
+          </a:p>
+        </p:txBody>
+      </p:sp>
+      <p:sp>
+        <p:nvSpPr>
+          <p:cNvPr id="22" name="TextBox 21"/>
+          <p:cNvSpPr txBox="1"/>
+          <p:nvPr/>
+        </p:nvSpPr>
+        <p:spPr>
+          <a:xfrm>
+            <a:off x="7196327" y="3959352"/>
+            <a:ext cx="4154119" cy="630936"/>
+          </a:xfrm>
+          <a:prstGeom prst="rect">
+            <a:avLst/>
+          </a:prstGeom>
+          <a:noFill/>
+        </p:spPr>
+        <p:txBody>
+          <a:bodyPr wrap="square" lIns="0" tIns="0" rIns="0" bIns="0" anchor="t">
+            <a:spAutoFit/>
+          </a:bodyPr>
+          <a:lstStyle/>
+          <a:p>
+            <a:pPr algn="l">
+              <a:lnSpc>
+                <a:spcPct val="135000"/>
+              </a:lnSpc>
+              <a:spcAft>
+                <a:spcPts val="0"/>
+              </a:spcAft>
+            </a:pPr>
+            <a:r>
+              <a:rPr sz="1800" b="0">
+                <a:solidFill>
+                  <a:srgbClr val="D4D4D8"/>
+                </a:solidFill>
+                <a:latin typeface="IBM Plex Sans Thai"/>
+                <a:ea typeface="IBM Plex Sans Thai"/>
+                <a:cs typeface="IBM Plex Sans Thai"/>
+              </a:rPr>
+              <a:t>business → ชื่อร้าน เบอร์ บัญชี</a:t>
+            </a:r>
+          </a:p>
+        </p:txBody>
+      </p:sp>
+      <p:cxnSp>
+        <p:nvCxnSpPr>
+          <p:cNvPr id="23" name="Connector 22"/>
+          <p:cNvCxnSpPr/>
+          <p:nvPr/>
+        </p:nvCxnSpPr>
+        <p:spPr>
+          <a:xfrm>
+            <a:off x="612648" y="4590288"/>
+            <a:ext cx="10966399" cy="0"/>
+          </a:xfrm>
+          <a:prstGeom prst="line">
+            <a:avLst/>
+          </a:prstGeom>
+          <a:ln w="9525">
+            <a:solidFill>
+              <a:srgbClr val="26262B"/>
+            </a:solidFill>
+          </a:ln>
+        </p:spPr>
+        <p:style>
+          <a:lnRef idx="2">
+            <a:schemeClr val="accent1"/>
+          </a:lnRef>
+          <a:fillRef idx="0">
+            <a:schemeClr val="accent1"/>
+          </a:fillRef>
+          <a:effectRef idx="1">
+            <a:schemeClr val="accent1"/>
+          </a:effectRef>
+          <a:fontRef idx="minor">
+            <a:schemeClr val="tx1"/>
+          </a:fontRef>
+        </p:style>
+      </p:cxnSp>
+      <p:sp>
+        <p:nvSpPr>
+          <p:cNvPr id="24" name="TextBox 23"/>
+          <p:cNvSpPr txBox="1"/>
+          <p:nvPr/>
+        </p:nvSpPr>
+        <p:spPr>
+          <a:xfrm>
+            <a:off x="612648" y="4736592"/>
+            <a:ext cx="2148840" cy="630936"/>
+          </a:xfrm>
+          <a:prstGeom prst="rect">
+            <a:avLst/>
+          </a:prstGeom>
+          <a:noFill/>
+        </p:spPr>
+        <p:txBody>
+          <a:bodyPr wrap="square" lIns="0" tIns="0" rIns="0" bIns="0" anchor="t">
+            <a:spAutoFit/>
+          </a:bodyPr>
+          <a:lstStyle/>
+          <a:p>
+            <a:pPr algn="l">
+              <a:lnSpc>
+                <a:spcPct val="135000"/>
+              </a:lnSpc>
+              <a:spcAft>
+                <a:spcPts val="0"/>
+              </a:spcAft>
+            </a:pPr>
+            <a:r>
+              <a:rPr sz="1700" b="0">
+                <a:solidFill>
+                  <a:srgbClr val="A3A3A8"/>
+                </a:solidFill>
+                <a:latin typeface="IBM Plex Sans Thai"/>
+                <a:ea typeface="IBM Plex Sans Thai"/>
+                <a:cs typeface="IBM Plex Sans Thai"/>
+              </a:rPr>
+              <a:t>แยกเป็นไฟล์</a:t>
+            </a:r>
+          </a:p>
+        </p:txBody>
+      </p:sp>
+      <p:sp>
+        <p:nvSpPr>
+          <p:cNvPr id="25" name="TextBox 24"/>
+          <p:cNvSpPr txBox="1"/>
+          <p:nvPr/>
+        </p:nvSpPr>
+        <p:spPr>
+          <a:xfrm>
+            <a:off x="2990088" y="4736592"/>
+            <a:ext cx="3977639" cy="630936"/>
+          </a:xfrm>
+          <a:prstGeom prst="rect">
+            <a:avLst/>
+          </a:prstGeom>
+          <a:noFill/>
+        </p:spPr>
+        <p:txBody>
+          <a:bodyPr wrap="square" lIns="0" tIns="0" rIns="0" bIns="0" anchor="t">
+            <a:spAutoFit/>
+          </a:bodyPr>
+          <a:lstStyle/>
+          <a:p>
+            <a:pPr algn="l">
+              <a:lnSpc>
+                <a:spcPct val="135000"/>
+              </a:lnSpc>
+              <a:spcAft>
+                <a:spcPts val="0"/>
+              </a:spcAft>
+            </a:pPr>
+            <a:r>
+              <a:rPr sz="2000" b="1">
+                <a:solidFill>
+                  <a:srgbClr val="F5F5F4"/>
+                </a:solidFill>
+                <a:latin typeface="IBM Plex Sans Thai"/>
+                <a:ea typeface="IBM Plex Sans Thai"/>
+                <a:cs typeface="IBM Plex Sans Thai"/>
+              </a:rPr>
+              <a:t>ดัชนี LightRAG</a:t>
+            </a:r>
+          </a:p>
+        </p:txBody>
+      </p:sp>
+      <p:sp>
+        <p:nvSpPr>
+          <p:cNvPr id="26" name="TextBox 25"/>
+          <p:cNvSpPr txBox="1"/>
+          <p:nvPr/>
+        </p:nvSpPr>
+        <p:spPr>
+          <a:xfrm>
+            <a:off x="7196327" y="4736592"/>
+            <a:ext cx="4154119" cy="630936"/>
+          </a:xfrm>
+          <a:prstGeom prst="rect">
+            <a:avLst/>
+          </a:prstGeom>
+          <a:noFill/>
+        </p:spPr>
+        <p:txBody>
+          <a:bodyPr wrap="square" lIns="0" tIns="0" rIns="0" bIns="0" anchor="t">
+            <a:spAutoFit/>
+          </a:bodyPr>
+          <a:lstStyle/>
+          <a:p>
+            <a:pPr algn="l">
+              <a:lnSpc>
+                <a:spcPct val="135000"/>
+              </a:lnSpc>
+              <a:spcAft>
+                <a:spcPts val="0"/>
+              </a:spcAft>
+            </a:pPr>
+            <a:r>
+              <a:rPr sz="1800" b="0">
+                <a:solidFill>
+                  <a:srgbClr val="D4D4D8"/>
+                </a:solidFill>
+                <a:latin typeface="IBM Plex Sans Thai"/>
+                <a:ea typeface="IBM Plex Sans Thai"/>
+                <a:cs typeface="IBM Plex Sans Thai"/>
+              </a:rPr>
+              <a:t>data/rag-index/ 13 ไฟล์ · 11 MB</a:t>
+            </a:r>
+          </a:p>
+        </p:txBody>
+      </p:sp>
+      <p:cxnSp>
+        <p:nvCxnSpPr>
+          <p:cNvPr id="27" name="Connector 26"/>
+          <p:cNvCxnSpPr/>
+          <p:nvPr/>
+        </p:nvCxnSpPr>
+        <p:spPr>
+          <a:xfrm>
+            <a:off x="612648" y="5367527"/>
+            <a:ext cx="10966399" cy="0"/>
+          </a:xfrm>
+          <a:prstGeom prst="line">
+            <a:avLst/>
+          </a:prstGeom>
+          <a:ln w="9525">
+            <a:solidFill>
+              <a:srgbClr val="26262B"/>
+            </a:solidFill>
+          </a:ln>
+        </p:spPr>
+        <p:style>
+          <a:lnRef idx="2">
+            <a:schemeClr val="accent1"/>
+          </a:lnRef>
+          <a:fillRef idx="0">
+            <a:schemeClr val="accent1"/>
+          </a:fillRef>
+          <a:effectRef idx="1">
+            <a:schemeClr val="accent1"/>
+          </a:effectRef>
+          <a:fontRef idx="minor">
+            <a:schemeClr val="tx1"/>
+          </a:fontRef>
+        </p:style>
+      </p:cxnSp>
+    </p:spTree>
+  </p:cSld>
+  <p:clrMapOvr>
+    <a:masterClrMapping/>
+  </p:clrMapOvr>
+</p:sld>
+</file>
+
+<file path=ppt/slides/slide36.xml><?xml version="1.0" encoding="utf-8"?>
+<p:sld xmlns:a="http://schemas.openxmlformats.org/drawingml/2006/main" xmlns:p="http://schemas.openxmlformats.org/presentationml/2006/main" xmlns:r="http://schemas.openxmlformats.org/officeDocument/2006/relationships">
+  <p:cSld>
+    <p:bg>
+      <p:bgPr>
+        <a:solidFill>
+          <a:srgbClr val="09090A"/>
+        </a:solidFill>
+        <a:effectLst/>
+      </p:bgPr>
+    </p:bg>
+    <p:spTree>
+      <p:nvGrpSpPr>
+        <p:cNvPr id="1" name=""/>
+        <p:cNvGrpSpPr/>
+        <p:nvPr/>
+      </p:nvGrpSpPr>
+      <p:grpSpPr/>
+      <p:sp>
+        <p:nvSpPr>
+          <p:cNvPr id="2" name="Rectangle 1"/>
+          <p:cNvSpPr/>
+          <p:nvPr/>
+        </p:nvSpPr>
+        <p:spPr>
+          <a:xfrm>
+            <a:off x="612648" y="566928"/>
+            <a:ext cx="109728" cy="109728"/>
+          </a:xfrm>
+          <a:prstGeom prst="rect">
+            <a:avLst/>
+          </a:prstGeom>
+          <a:solidFill>
+            <a:srgbClr val="E10613"/>
+          </a:solidFill>
+          <a:ln>
+            <a:noFill/>
+          </a:ln>
+          <a:effectLst/>
+        </p:spPr>
+        <p:style>
+          <a:lnRef idx="1">
+            <a:schemeClr val="accent1"/>
+          </a:lnRef>
+          <a:fillRef idx="3">
+            <a:schemeClr val="accent1"/>
+          </a:fillRef>
+          <a:effectRef idx="2">
+            <a:schemeClr val="accent1"/>
+          </a:effectRef>
+          <a:fontRef idx="minor">
+            <a:schemeClr val="lt1"/>
+          </a:fontRef>
+        </p:style>
+        <p:txBody>
+          <a:bodyPr rtlCol="0" anchor="ctr"/>
+          <a:lstStyle/>
+          <a:p>
+            <a:pPr algn="ctr"/>
+            <a:endParaRPr/>
+          </a:p>
+        </p:txBody>
+      </p:sp>
+      <p:sp>
+        <p:nvSpPr>
+          <p:cNvPr id="3" name="TextBox 2"/>
+          <p:cNvSpPr txBox="1"/>
+          <p:nvPr/>
+        </p:nvSpPr>
+        <p:spPr>
+          <a:xfrm>
+            <a:off x="832104" y="475488"/>
+            <a:ext cx="7315200" cy="274320"/>
+          </a:xfrm>
+          <a:prstGeom prst="rect">
+            <a:avLst/>
+          </a:prstGeom>
+          <a:noFill/>
+        </p:spPr>
+        <p:txBody>
+          <a:bodyPr wrap="square" lIns="0" tIns="0" rIns="0" bIns="0" anchor="t">
+            <a:spAutoFit/>
+          </a:bodyPr>
+          <a:lstStyle/>
+          <a:p>
+            <a:pPr algn="l">
+              <a:lnSpc>
+                <a:spcPct val="100000"/>
+              </a:lnSpc>
+              <a:spcAft>
+                <a:spcPts val="0"/>
+              </a:spcAft>
+            </a:pPr>
+            <a:r>
+              <a:rPr sz="1200" b="1">
+                <a:solidFill>
+                  <a:srgbClr val="A3A3A8"/>
+                </a:solidFill>
+                <a:latin typeface="Chakra Petch"/>
+                <a:ea typeface="Chakra Petch"/>
+                <a:cs typeface="Chakra Petch"/>
+              </a:rPr>
+              <a:t>องค์ประกอบของระบบ</a:t>
+            </a:r>
+          </a:p>
+        </p:txBody>
+      </p:sp>
+      <p:sp>
+        <p:nvSpPr>
+          <p:cNvPr id="4" name="TextBox 3"/>
+          <p:cNvSpPr txBox="1"/>
+          <p:nvPr/>
+        </p:nvSpPr>
+        <p:spPr>
+          <a:xfrm>
+            <a:off x="612648" y="841248"/>
+            <a:ext cx="10966399" cy="822960"/>
+          </a:xfrm>
+          <a:prstGeom prst="rect">
+            <a:avLst/>
+          </a:prstGeom>
+          <a:noFill/>
+        </p:spPr>
+        <p:txBody>
+          <a:bodyPr wrap="square" lIns="0" tIns="0" rIns="0" bIns="0" anchor="t">
+            <a:spAutoFit/>
+          </a:bodyPr>
+          <a:lstStyle/>
+          <a:p>
+            <a:pPr algn="l">
+              <a:lnSpc>
+                <a:spcPct val="115000"/>
+              </a:lnSpc>
+              <a:spcAft>
+                <a:spcPts val="0"/>
+              </a:spcAft>
+            </a:pPr>
+            <a:r>
+              <a:rPr sz="2800" b="1">
+                <a:solidFill>
+                  <a:srgbClr val="F5F5F4"/>
+                </a:solidFill>
+                <a:latin typeface="Chakra Petch"/>
+                <a:ea typeface="Chakra Petch"/>
+                <a:cs typeface="Chakra Petch"/>
+              </a:rPr>
+              <a:t>พจนานุกรมข้อมูล: ตาราง members (ดูครบทุกตารางได้ในหลังบ้าน)</a:t>
+            </a:r>
+          </a:p>
+        </p:txBody>
+      </p:sp>
+      <p:cxnSp>
+        <p:nvCxnSpPr>
+          <p:cNvPr id="5" name="Connector 4"/>
+          <p:cNvCxnSpPr/>
+          <p:nvPr/>
+        </p:nvCxnSpPr>
+        <p:spPr>
+          <a:xfrm>
+            <a:off x="612648" y="6291072"/>
+            <a:ext cx="10966399" cy="0"/>
+          </a:xfrm>
+          <a:prstGeom prst="line">
+            <a:avLst/>
+          </a:prstGeom>
+          <a:ln w="9525">
+            <a:solidFill>
+              <a:srgbClr val="26262B"/>
+            </a:solidFill>
+          </a:ln>
+        </p:spPr>
+        <p:style>
+          <a:lnRef idx="2">
+            <a:schemeClr val="accent1"/>
+          </a:lnRef>
+          <a:fillRef idx="0">
+            <a:schemeClr val="accent1"/>
+          </a:fillRef>
+          <a:effectRef idx="1">
+            <a:schemeClr val="accent1"/>
+          </a:effectRef>
+          <a:fontRef idx="minor">
+            <a:schemeClr val="tx1"/>
+          </a:fontRef>
+        </p:style>
+      </p:cxnSp>
+      <p:sp>
+        <p:nvSpPr>
+          <p:cNvPr id="6" name="TextBox 5"/>
+          <p:cNvSpPr txBox="1"/>
+          <p:nvPr/>
+        </p:nvSpPr>
+        <p:spPr>
+          <a:xfrm>
+            <a:off x="612648" y="6400800"/>
+            <a:ext cx="7315200" cy="274320"/>
+          </a:xfrm>
+          <a:prstGeom prst="rect">
+            <a:avLst/>
+          </a:prstGeom>
+          <a:noFill/>
+        </p:spPr>
+        <p:txBody>
+          <a:bodyPr wrap="square" lIns="0" tIns="0" rIns="0" bIns="0" anchor="t">
+            <a:spAutoFit/>
+          </a:bodyPr>
+          <a:lstStyle/>
+          <a:p>
+            <a:pPr algn="l">
+              <a:lnSpc>
+                <a:spcPct val="100000"/>
+              </a:lnSpc>
+              <a:spcAft>
+                <a:spcPts val="0"/>
+              </a:spcAft>
+            </a:pPr>
+            <a:r>
+              <a:rPr sz="1100" b="0">
+                <a:solidFill>
+                  <a:srgbClr val="6B6B72"/>
+                </a:solidFill>
+                <a:latin typeface="Chakra Petch"/>
+                <a:ea typeface="Chakra Petch"/>
+                <a:cs typeface="Chakra Petch"/>
+              </a:rPr>
+              <a:t>X FITNESS CHATBOT   ·   องค์ประกอบของระบบ</a:t>
+            </a:r>
+          </a:p>
+        </p:txBody>
+      </p:sp>
+      <p:sp>
+        <p:nvSpPr>
+          <p:cNvPr id="7" name="TextBox 6"/>
+          <p:cNvSpPr txBox="1"/>
+          <p:nvPr/>
+        </p:nvSpPr>
+        <p:spPr>
+          <a:xfrm>
+            <a:off x="10664647" y="6400800"/>
+            <a:ext cx="914400" cy="274320"/>
+          </a:xfrm>
+          <a:prstGeom prst="rect">
+            <a:avLst/>
+          </a:prstGeom>
+          <a:noFill/>
+        </p:spPr>
+        <p:txBody>
+          <a:bodyPr wrap="square" lIns="0" tIns="0" rIns="0" bIns="0" anchor="t">
+            <a:spAutoFit/>
+          </a:bodyPr>
+          <a:lstStyle/>
+          <a:p>
+            <a:pPr algn="r">
+              <a:lnSpc>
+                <a:spcPct val="100000"/>
+              </a:lnSpc>
+              <a:spcAft>
+                <a:spcPts val="0"/>
+              </a:spcAft>
+            </a:pPr>
+            <a:r>
+              <a:rPr sz="1100" b="0">
+                <a:solidFill>
+                  <a:srgbClr val="A3A3A8"/>
+                </a:solidFill>
+                <a:latin typeface="Chakra Petch"/>
+                <a:ea typeface="Chakra Petch"/>
+                <a:cs typeface="Chakra Petch"/>
+              </a:rPr>
+              <a:t>15</a:t>
+            </a:r>
+          </a:p>
+        </p:txBody>
+      </p:sp>
+      <p:sp>
+        <p:nvSpPr>
+          <p:cNvPr id="8" name="TextBox 7"/>
+          <p:cNvSpPr txBox="1"/>
+          <p:nvPr/>
+        </p:nvSpPr>
+        <p:spPr>
+          <a:xfrm>
+            <a:off x="612648" y="1874519"/>
+            <a:ext cx="2194560" cy="274320"/>
+          </a:xfrm>
+          <a:prstGeom prst="rect">
+            <a:avLst/>
+          </a:prstGeom>
+          <a:noFill/>
+        </p:spPr>
+        <p:txBody>
+          <a:bodyPr wrap="square" lIns="0" tIns="0" rIns="0" bIns="0" anchor="t">
+            <a:spAutoFit/>
+          </a:bodyPr>
+          <a:lstStyle/>
+          <a:p>
+            <a:pPr algn="l">
+              <a:lnSpc>
+                <a:spcPct val="100000"/>
+              </a:lnSpc>
+              <a:spcAft>
+                <a:spcPts val="0"/>
+              </a:spcAft>
+            </a:pPr>
+            <a:r>
+              <a:rPr sz="1200" b="1">
+                <a:solidFill>
+                  <a:srgbClr val="6B6B72"/>
+                </a:solidFill>
+                <a:latin typeface="Chakra Petch"/>
+                <a:ea typeface="Chakra Petch"/>
+                <a:cs typeface="Chakra Petch"/>
+              </a:rPr>
+              <a:t>คอลัมน์</a:t>
+            </a:r>
+          </a:p>
+        </p:txBody>
+      </p:sp>
+      <p:sp>
+        <p:nvSpPr>
+          <p:cNvPr id="9" name="TextBox 8"/>
+          <p:cNvSpPr txBox="1"/>
+          <p:nvPr/>
+        </p:nvSpPr>
+        <p:spPr>
+          <a:xfrm>
+            <a:off x="2990088" y="1874519"/>
+            <a:ext cx="4023359" cy="274320"/>
+          </a:xfrm>
+          <a:prstGeom prst="rect">
+            <a:avLst/>
+          </a:prstGeom>
+          <a:noFill/>
+        </p:spPr>
+        <p:txBody>
+          <a:bodyPr wrap="square" lIns="0" tIns="0" rIns="0" bIns="0" anchor="t">
+            <a:spAutoFit/>
+          </a:bodyPr>
+          <a:lstStyle/>
+          <a:p>
+            <a:pPr algn="l">
+              <a:lnSpc>
+                <a:spcPct val="100000"/>
+              </a:lnSpc>
+              <a:spcAft>
+                <a:spcPts val="0"/>
+              </a:spcAft>
+            </a:pPr>
+            <a:r>
+              <a:rPr sz="1200" b="1">
+                <a:solidFill>
+                  <a:srgbClr val="6B6B72"/>
+                </a:solidFill>
+                <a:latin typeface="Chakra Petch"/>
+                <a:ea typeface="Chakra Petch"/>
+                <a:cs typeface="Chakra Petch"/>
+              </a:rPr>
+              <a:t>ความหมาย</a:t>
+            </a:r>
+          </a:p>
+        </p:txBody>
+      </p:sp>
+      <p:sp>
+        <p:nvSpPr>
+          <p:cNvPr id="10" name="TextBox 9"/>
+          <p:cNvSpPr txBox="1"/>
+          <p:nvPr/>
+        </p:nvSpPr>
+        <p:spPr>
+          <a:xfrm>
+            <a:off x="7196327" y="1874519"/>
+            <a:ext cx="4199839" cy="274320"/>
+          </a:xfrm>
+          <a:prstGeom prst="rect">
+            <a:avLst/>
+          </a:prstGeom>
+          <a:noFill/>
+        </p:spPr>
+        <p:txBody>
+          <a:bodyPr wrap="square" lIns="0" tIns="0" rIns="0" bIns="0" anchor="t">
+            <a:spAutoFit/>
+          </a:bodyPr>
+          <a:lstStyle/>
+          <a:p>
+            <a:pPr algn="l">
+              <a:lnSpc>
+                <a:spcPct val="100000"/>
+              </a:lnSpc>
+              <a:spcAft>
+                <a:spcPts val="0"/>
+              </a:spcAft>
+            </a:pPr>
+            <a:r>
+              <a:rPr sz="1200" b="1">
+                <a:solidFill>
+                  <a:srgbClr val="6B6B72"/>
+                </a:solidFill>
+                <a:latin typeface="Chakra Petch"/>
+                <a:ea typeface="Chakra Petch"/>
+                <a:cs typeface="Chakra Petch"/>
+              </a:rPr>
+              <a:t>ตัวอย่าง</a:t>
+            </a:r>
+          </a:p>
+        </p:txBody>
+      </p:sp>
+      <p:cxnSp>
+        <p:nvCxnSpPr>
+          <p:cNvPr id="11" name="Connector 10"/>
+          <p:cNvCxnSpPr/>
+          <p:nvPr/>
+        </p:nvCxnSpPr>
+        <p:spPr>
+          <a:xfrm>
+            <a:off x="612648" y="2258568"/>
+            <a:ext cx="10966399" cy="0"/>
+          </a:xfrm>
+          <a:prstGeom prst="line">
+            <a:avLst/>
+          </a:prstGeom>
+          <a:ln w="9525">
+            <a:solidFill>
+              <a:srgbClr val="34343C"/>
+            </a:solidFill>
+          </a:ln>
+        </p:spPr>
+        <p:style>
+          <a:lnRef idx="2">
+            <a:schemeClr val="accent1"/>
+          </a:lnRef>
+          <a:fillRef idx="0">
+            <a:schemeClr val="accent1"/>
+          </a:fillRef>
+          <a:effectRef idx="1">
+            <a:schemeClr val="accent1"/>
+          </a:effectRef>
+          <a:fontRef idx="minor">
+            <a:schemeClr val="tx1"/>
+          </a:fontRef>
+        </p:style>
+      </p:cxnSp>
+      <p:sp>
+        <p:nvSpPr>
+          <p:cNvPr id="12" name="TextBox 11"/>
+          <p:cNvSpPr txBox="1"/>
+          <p:nvPr/>
+        </p:nvSpPr>
+        <p:spPr>
+          <a:xfrm>
+            <a:off x="612648" y="2404872"/>
+            <a:ext cx="2148840" cy="630936"/>
+          </a:xfrm>
+          <a:prstGeom prst="rect">
+            <a:avLst/>
+          </a:prstGeom>
+          <a:noFill/>
+        </p:spPr>
+        <p:txBody>
+          <a:bodyPr wrap="square" lIns="0" tIns="0" rIns="0" bIns="0" anchor="t">
+            <a:spAutoFit/>
+          </a:bodyPr>
+          <a:lstStyle/>
+          <a:p>
+            <a:pPr algn="l">
+              <a:lnSpc>
+                <a:spcPct val="135000"/>
+              </a:lnSpc>
+              <a:spcAft>
+                <a:spcPts val="0"/>
+              </a:spcAft>
+            </a:pPr>
+            <a:r>
+              <a:rPr sz="1700" b="0">
+                <a:solidFill>
+                  <a:srgbClr val="A3A3A8"/>
+                </a:solidFill>
+                <a:latin typeface="IBM Plex Sans Thai"/>
+                <a:ea typeface="IBM Plex Sans Thai"/>
+                <a:cs typeface="IBM Plex Sans Thai"/>
+              </a:rPr>
+              <a:t>member_id</a:t>
+            </a:r>
+          </a:p>
+        </p:txBody>
+      </p:sp>
+      <p:sp>
+        <p:nvSpPr>
+          <p:cNvPr id="13" name="TextBox 12"/>
+          <p:cNvSpPr txBox="1"/>
+          <p:nvPr/>
+        </p:nvSpPr>
+        <p:spPr>
+          <a:xfrm>
+            <a:off x="2990088" y="2404872"/>
+            <a:ext cx="3977639" cy="630936"/>
+          </a:xfrm>
+          <a:prstGeom prst="rect">
+            <a:avLst/>
+          </a:prstGeom>
+          <a:noFill/>
+        </p:spPr>
+        <p:txBody>
+          <a:bodyPr wrap="square" lIns="0" tIns="0" rIns="0" bIns="0" anchor="t">
+            <a:spAutoFit/>
+          </a:bodyPr>
+          <a:lstStyle/>
+          <a:p>
+            <a:pPr algn="l">
+              <a:lnSpc>
+                <a:spcPct val="135000"/>
+              </a:lnSpc>
+              <a:spcAft>
+                <a:spcPts val="0"/>
+              </a:spcAft>
+            </a:pPr>
+            <a:r>
+              <a:rPr sz="2000" b="1">
+                <a:solidFill>
+                  <a:srgbClr val="F5F5F4"/>
+                </a:solidFill>
+                <a:latin typeface="IBM Plex Sans Thai"/>
+                <a:ea typeface="IBM Plex Sans Thai"/>
+                <a:cs typeface="IBM Plex Sans Thai"/>
+              </a:rPr>
+              <a:t>รหัสสมาชิก</a:t>
+            </a:r>
+          </a:p>
+        </p:txBody>
+      </p:sp>
+      <p:sp>
+        <p:nvSpPr>
+          <p:cNvPr id="14" name="TextBox 13"/>
+          <p:cNvSpPr txBox="1"/>
+          <p:nvPr/>
+        </p:nvSpPr>
+        <p:spPr>
+          <a:xfrm>
+            <a:off x="7196327" y="2404872"/>
+            <a:ext cx="4154119" cy="630936"/>
+          </a:xfrm>
+          <a:prstGeom prst="rect">
+            <a:avLst/>
+          </a:prstGeom>
+          <a:noFill/>
+        </p:spPr>
+        <p:txBody>
+          <a:bodyPr wrap="square" lIns="0" tIns="0" rIns="0" bIns="0" anchor="t">
+            <a:spAutoFit/>
+          </a:bodyPr>
+          <a:lstStyle/>
+          <a:p>
+            <a:pPr algn="l">
+              <a:lnSpc>
+                <a:spcPct val="135000"/>
+              </a:lnSpc>
+              <a:spcAft>
+                <a:spcPts val="0"/>
+              </a:spcAft>
+            </a:pPr>
+            <a:r>
+              <a:rPr sz="1800" b="0">
+                <a:solidFill>
+                  <a:srgbClr val="D4D4D8"/>
+                </a:solidFill>
+                <a:latin typeface="IBM Plex Sans Thai"/>
+                <a:ea typeface="IBM Plex Sans Thai"/>
+                <a:cs typeface="IBM Plex Sans Thai"/>
+              </a:rPr>
+              <a:t>FN-10001</a:t>
+            </a:r>
+          </a:p>
+        </p:txBody>
+      </p:sp>
+      <p:cxnSp>
+        <p:nvCxnSpPr>
+          <p:cNvPr id="15" name="Connector 14"/>
+          <p:cNvCxnSpPr/>
+          <p:nvPr/>
+        </p:nvCxnSpPr>
+        <p:spPr>
+          <a:xfrm>
+            <a:off x="612648" y="3035808"/>
+            <a:ext cx="10966399" cy="0"/>
+          </a:xfrm>
+          <a:prstGeom prst="line">
+            <a:avLst/>
+          </a:prstGeom>
+          <a:ln w="9525">
+            <a:solidFill>
+              <a:srgbClr val="26262B"/>
+            </a:solidFill>
+          </a:ln>
+        </p:spPr>
+        <p:style>
+          <a:lnRef idx="2">
+            <a:schemeClr val="accent1"/>
+          </a:lnRef>
+          <a:fillRef idx="0">
+            <a:schemeClr val="accent1"/>
+          </a:fillRef>
+          <a:effectRef idx="1">
+            <a:schemeClr val="accent1"/>
+          </a:effectRef>
+          <a:fontRef idx="minor">
+            <a:schemeClr val="tx1"/>
+          </a:fontRef>
+        </p:style>
+      </p:cxnSp>
+      <p:sp>
+        <p:nvSpPr>
+          <p:cNvPr id="16" name="TextBox 15"/>
+          <p:cNvSpPr txBox="1"/>
+          <p:nvPr/>
+        </p:nvSpPr>
+        <p:spPr>
+          <a:xfrm>
+            <a:off x="612648" y="3182112"/>
+            <a:ext cx="2148840" cy="630936"/>
+          </a:xfrm>
+          <a:prstGeom prst="rect">
+            <a:avLst/>
+          </a:prstGeom>
+          <a:noFill/>
+        </p:spPr>
+        <p:txBody>
+          <a:bodyPr wrap="square" lIns="0" tIns="0" rIns="0" bIns="0" anchor="t">
+            <a:spAutoFit/>
+          </a:bodyPr>
+          <a:lstStyle/>
+          <a:p>
+            <a:pPr algn="l">
+              <a:lnSpc>
+                <a:spcPct val="135000"/>
+              </a:lnSpc>
+              <a:spcAft>
+                <a:spcPts val="0"/>
+              </a:spcAft>
+            </a:pPr>
+            <a:r>
+              <a:rPr sz="1700" b="0">
+                <a:solidFill>
+                  <a:srgbClr val="A3A3A8"/>
+                </a:solidFill>
+                <a:latin typeface="IBM Plex Sans Thai"/>
+                <a:ea typeface="IBM Plex Sans Thai"/>
+                <a:cs typeface="IBM Plex Sans Thai"/>
+              </a:rPr>
+              <a:t>phone_last4</a:t>
+            </a:r>
+          </a:p>
+        </p:txBody>
+      </p:sp>
+      <p:sp>
+        <p:nvSpPr>
+          <p:cNvPr id="17" name="TextBox 16"/>
+          <p:cNvSpPr txBox="1"/>
+          <p:nvPr/>
+        </p:nvSpPr>
+        <p:spPr>
+          <a:xfrm>
+            <a:off x="2990088" y="3182112"/>
+            <a:ext cx="3977639" cy="630936"/>
+          </a:xfrm>
+          <a:prstGeom prst="rect">
+            <a:avLst/>
+          </a:prstGeom>
+          <a:noFill/>
+        </p:spPr>
+        <p:txBody>
+          <a:bodyPr wrap="square" lIns="0" tIns="0" rIns="0" bIns="0" anchor="t">
+            <a:spAutoFit/>
+          </a:bodyPr>
+          <a:lstStyle/>
+          <a:p>
+            <a:pPr algn="l">
+              <a:lnSpc>
+                <a:spcPct val="135000"/>
+              </a:lnSpc>
+              <a:spcAft>
+                <a:spcPts val="0"/>
+              </a:spcAft>
+            </a:pPr>
+            <a:r>
+              <a:rPr sz="2000" b="1">
+                <a:solidFill>
+                  <a:srgbClr val="F5F5F4"/>
+                </a:solidFill>
+                <a:latin typeface="IBM Plex Sans Thai"/>
+                <a:ea typeface="IBM Plex Sans Thai"/>
+                <a:cs typeface="IBM Plex Sans Thai"/>
+              </a:rPr>
+              <a:t>เบอร์ 4 ตัวท้าย ใช้ยืนยันตัวตน</a:t>
+            </a:r>
+          </a:p>
+        </p:txBody>
+      </p:sp>
+      <p:sp>
+        <p:nvSpPr>
+          <p:cNvPr id="18" name="TextBox 17"/>
+          <p:cNvSpPr txBox="1"/>
+          <p:nvPr/>
+        </p:nvSpPr>
+        <p:spPr>
+          <a:xfrm>
+            <a:off x="7196327" y="3182112"/>
+            <a:ext cx="4154119" cy="630936"/>
+          </a:xfrm>
+          <a:prstGeom prst="rect">
+            <a:avLst/>
+          </a:prstGeom>
+          <a:noFill/>
+        </p:spPr>
+        <p:txBody>
+          <a:bodyPr wrap="square" lIns="0" tIns="0" rIns="0" bIns="0" anchor="t">
+            <a:spAutoFit/>
+          </a:bodyPr>
+          <a:lstStyle/>
+          <a:p>
+            <a:pPr algn="l">
+              <a:lnSpc>
+                <a:spcPct val="135000"/>
+              </a:lnSpc>
+              <a:spcAft>
+                <a:spcPts val="0"/>
+              </a:spcAft>
+            </a:pPr>
+            <a:r>
+              <a:rPr sz="1800" b="0">
+                <a:solidFill>
+                  <a:srgbClr val="D4D4D8"/>
+                </a:solidFill>
+                <a:latin typeface="IBM Plex Sans Thai"/>
+                <a:ea typeface="IBM Plex Sans Thai"/>
+                <a:cs typeface="IBM Plex Sans Thai"/>
+              </a:rPr>
+              <a:t>0417 · เบอร์เต็มเก็บไว้ แต่บอทไม่เคยบอก</a:t>
+            </a:r>
+          </a:p>
+        </p:txBody>
+      </p:sp>
+      <p:cxnSp>
+        <p:nvCxnSpPr>
+          <p:cNvPr id="19" name="Connector 18"/>
+          <p:cNvCxnSpPr/>
+          <p:nvPr/>
+        </p:nvCxnSpPr>
+        <p:spPr>
+          <a:xfrm>
+            <a:off x="612648" y="3813048"/>
+            <a:ext cx="10966399" cy="0"/>
+          </a:xfrm>
+          <a:prstGeom prst="line">
+            <a:avLst/>
+          </a:prstGeom>
+          <a:ln w="9525">
+            <a:solidFill>
+              <a:srgbClr val="26262B"/>
+            </a:solidFill>
+          </a:ln>
+        </p:spPr>
+        <p:style>
+          <a:lnRef idx="2">
+            <a:schemeClr val="accent1"/>
+          </a:lnRef>
+          <a:fillRef idx="0">
+            <a:schemeClr val="accent1"/>
+          </a:fillRef>
+          <a:effectRef idx="1">
+            <a:schemeClr val="accent1"/>
+          </a:effectRef>
+          <a:fontRef idx="minor">
+            <a:schemeClr val="tx1"/>
+          </a:fontRef>
+        </p:style>
+      </p:cxnSp>
+      <p:sp>
+        <p:nvSpPr>
+          <p:cNvPr id="20" name="TextBox 19"/>
+          <p:cNvSpPr txBox="1"/>
+          <p:nvPr/>
+        </p:nvSpPr>
+        <p:spPr>
+          <a:xfrm>
+            <a:off x="612648" y="3959352"/>
+            <a:ext cx="2148840" cy="630936"/>
+          </a:xfrm>
+          <a:prstGeom prst="rect">
+            <a:avLst/>
+          </a:prstGeom>
+          <a:noFill/>
+        </p:spPr>
+        <p:txBody>
+          <a:bodyPr wrap="square" lIns="0" tIns="0" rIns="0" bIns="0" anchor="t">
+            <a:spAutoFit/>
+          </a:bodyPr>
+          <a:lstStyle/>
+          <a:p>
+            <a:pPr algn="l">
+              <a:lnSpc>
+                <a:spcPct val="135000"/>
+              </a:lnSpc>
+              <a:spcAft>
+                <a:spcPts val="0"/>
+              </a:spcAft>
+            </a:pPr>
+            <a:r>
+              <a:rPr sz="1700" b="0">
+                <a:solidFill>
+                  <a:srgbClr val="A3A3A8"/>
+                </a:solidFill>
+                <a:latin typeface="IBM Plex Sans Thai"/>
+                <a:ea typeface="IBM Plex Sans Thai"/>
+                <a:cs typeface="IBM Plex Sans Thai"/>
+              </a:rPr>
+              <a:t>package_id</a:t>
+            </a:r>
+          </a:p>
+        </p:txBody>
+      </p:sp>
+      <p:sp>
+        <p:nvSpPr>
+          <p:cNvPr id="21" name="TextBox 20"/>
+          <p:cNvSpPr txBox="1"/>
+          <p:nvPr/>
+        </p:nvSpPr>
+        <p:spPr>
+          <a:xfrm>
+            <a:off x="2990088" y="3959352"/>
+            <a:ext cx="3977639" cy="630936"/>
+          </a:xfrm>
+          <a:prstGeom prst="rect">
+            <a:avLst/>
+          </a:prstGeom>
+          <a:noFill/>
+        </p:spPr>
+        <p:txBody>
+          <a:bodyPr wrap="square" lIns="0" tIns="0" rIns="0" bIns="0" anchor="t">
+            <a:spAutoFit/>
+          </a:bodyPr>
+          <a:lstStyle/>
+          <a:p>
+            <a:pPr algn="l">
+              <a:lnSpc>
+                <a:spcPct val="135000"/>
+              </a:lnSpc>
+              <a:spcAft>
+                <a:spcPts val="0"/>
+              </a:spcAft>
+            </a:pPr>
+            <a:r>
+              <a:rPr sz="2000" b="1">
+                <a:solidFill>
+                  <a:srgbClr val="F5F5F4"/>
+                </a:solidFill>
+                <a:latin typeface="IBM Plex Sans Thai"/>
+                <a:ea typeface="IBM Plex Sans Thai"/>
+                <a:cs typeface="IBM Plex Sans Thai"/>
+              </a:rPr>
+              <a:t>แพ็กเกจ → packages.id</a:t>
+            </a:r>
+          </a:p>
+        </p:txBody>
+      </p:sp>
+      <p:sp>
+        <p:nvSpPr>
+          <p:cNvPr id="22" name="TextBox 21"/>
+          <p:cNvSpPr txBox="1"/>
+          <p:nvPr/>
+        </p:nvSpPr>
+        <p:spPr>
+          <a:xfrm>
+            <a:off x="7196327" y="3959352"/>
+            <a:ext cx="4154119" cy="630936"/>
+          </a:xfrm>
+          <a:prstGeom prst="rect">
+            <a:avLst/>
+          </a:prstGeom>
+          <a:noFill/>
+        </p:spPr>
+        <p:txBody>
+          <a:bodyPr wrap="square" lIns="0" tIns="0" rIns="0" bIns="0" anchor="t">
+            <a:spAutoFit/>
+          </a:bodyPr>
+          <a:lstStyle/>
+          <a:p>
+            <a:pPr algn="l">
+              <a:lnSpc>
+                <a:spcPct val="135000"/>
+              </a:lnSpc>
+              <a:spcAft>
+                <a:spcPts val="0"/>
+              </a:spcAft>
+            </a:pPr>
+            <a:r>
+              <a:rPr sz="1800" b="0">
+                <a:solidFill>
+                  <a:srgbClr val="D4D4D8"/>
+                </a:solidFill>
+                <a:latin typeface="IBM Plex Sans Thai"/>
+                <a:ea typeface="IBM Plex Sans Thai"/>
+                <a:cs typeface="IBM Plex Sans Thai"/>
+              </a:rPr>
+              <a:t>PKG-12M (รายเดือนสัญญา 12 เดือน)</a:t>
+            </a:r>
+          </a:p>
+        </p:txBody>
+      </p:sp>
+      <p:cxnSp>
+        <p:nvCxnSpPr>
+          <p:cNvPr id="23" name="Connector 22"/>
+          <p:cNvCxnSpPr/>
+          <p:nvPr/>
+        </p:nvCxnSpPr>
+        <p:spPr>
+          <a:xfrm>
+            <a:off x="612648" y="4590288"/>
+            <a:ext cx="10966399" cy="0"/>
+          </a:xfrm>
+          <a:prstGeom prst="line">
+            <a:avLst/>
+          </a:prstGeom>
+          <a:ln w="9525">
+            <a:solidFill>
+              <a:srgbClr val="26262B"/>
+            </a:solidFill>
+          </a:ln>
+        </p:spPr>
+        <p:style>
+          <a:lnRef idx="2">
+            <a:schemeClr val="accent1"/>
+          </a:lnRef>
+          <a:fillRef idx="0">
+            <a:schemeClr val="accent1"/>
+          </a:fillRef>
+          <a:effectRef idx="1">
+            <a:schemeClr val="accent1"/>
+          </a:effectRef>
+          <a:fontRef idx="minor">
+            <a:schemeClr val="tx1"/>
+          </a:fontRef>
+        </p:style>
+      </p:cxnSp>
+      <p:sp>
+        <p:nvSpPr>
+          <p:cNvPr id="24" name="TextBox 23"/>
+          <p:cNvSpPr txBox="1"/>
+          <p:nvPr/>
+        </p:nvSpPr>
+        <p:spPr>
+          <a:xfrm>
+            <a:off x="612648" y="4736592"/>
+            <a:ext cx="2148840" cy="630936"/>
+          </a:xfrm>
+          <a:prstGeom prst="rect">
+            <a:avLst/>
+          </a:prstGeom>
+          <a:noFill/>
+        </p:spPr>
+        <p:txBody>
+          <a:bodyPr wrap="square" lIns="0" tIns="0" rIns="0" bIns="0" anchor="t">
+            <a:spAutoFit/>
+          </a:bodyPr>
+          <a:lstStyle/>
+          <a:p>
+            <a:pPr algn="l">
+              <a:lnSpc>
+                <a:spcPct val="135000"/>
+              </a:lnSpc>
+              <a:spcAft>
+                <a:spcPts val="0"/>
+              </a:spcAft>
+            </a:pPr>
+            <a:r>
+              <a:rPr sz="1700" b="0">
+                <a:solidFill>
+                  <a:srgbClr val="A3A3A8"/>
+                </a:solidFill>
+                <a:latin typeface="IBM Plex Sans Thai"/>
+                <a:ea typeface="IBM Plex Sans Thai"/>
+                <a:cs typeface="IBM Plex Sans Thai"/>
+              </a:rPr>
+              <a:t>points · end_date</a:t>
+            </a:r>
+          </a:p>
+        </p:txBody>
+      </p:sp>
+      <p:sp>
+        <p:nvSpPr>
+          <p:cNvPr id="25" name="TextBox 24"/>
+          <p:cNvSpPr txBox="1"/>
+          <p:nvPr/>
+        </p:nvSpPr>
+        <p:spPr>
+          <a:xfrm>
+            <a:off x="2990088" y="4736592"/>
+            <a:ext cx="3977639" cy="630936"/>
+          </a:xfrm>
+          <a:prstGeom prst="rect">
+            <a:avLst/>
+          </a:prstGeom>
+          <a:noFill/>
+        </p:spPr>
+        <p:txBody>
+          <a:bodyPr wrap="square" lIns="0" tIns="0" rIns="0" bIns="0" anchor="t">
+            <a:spAutoFit/>
+          </a:bodyPr>
+          <a:lstStyle/>
+          <a:p>
+            <a:pPr algn="l">
+              <a:lnSpc>
+                <a:spcPct val="135000"/>
+              </a:lnSpc>
+              <a:spcAft>
+                <a:spcPts val="0"/>
+              </a:spcAft>
+            </a:pPr>
+            <a:r>
+              <a:rPr sz="2000" b="1">
+                <a:solidFill>
+                  <a:srgbClr val="F5F5F4"/>
+                </a:solidFill>
+                <a:latin typeface="IBM Plex Sans Thai"/>
+                <a:ea typeface="IBM Plex Sans Thai"/>
+                <a:cs typeface="IBM Plex Sans Thai"/>
+              </a:rPr>
+              <a:t>แต้มสะสม · วันหมดอายุ</a:t>
+            </a:r>
+          </a:p>
+        </p:txBody>
+      </p:sp>
+      <p:sp>
+        <p:nvSpPr>
+          <p:cNvPr id="26" name="TextBox 25"/>
+          <p:cNvSpPr txBox="1"/>
+          <p:nvPr/>
+        </p:nvSpPr>
+        <p:spPr>
+          <a:xfrm>
+            <a:off x="7196327" y="4736592"/>
+            <a:ext cx="4154119" cy="630936"/>
+          </a:xfrm>
+          <a:prstGeom prst="rect">
+            <a:avLst/>
+          </a:prstGeom>
+          <a:noFill/>
+        </p:spPr>
+        <p:txBody>
+          <a:bodyPr wrap="square" lIns="0" tIns="0" rIns="0" bIns="0" anchor="t">
+            <a:spAutoFit/>
+          </a:bodyPr>
+          <a:lstStyle/>
+          <a:p>
+            <a:pPr algn="l">
+              <a:lnSpc>
+                <a:spcPct val="135000"/>
+              </a:lnSpc>
+              <a:spcAft>
+                <a:spcPts val="0"/>
+              </a:spcAft>
+            </a:pPr>
+            <a:r>
+              <a:rPr sz="1800" b="0">
+                <a:solidFill>
+                  <a:srgbClr val="D4D4D8"/>
+                </a:solidFill>
+                <a:latin typeface="IBM Plex Sans Thai"/>
+                <a:ea typeface="IBM Plex Sans Thai"/>
+                <a:cs typeface="IBM Plex Sans Thai"/>
+              </a:rPr>
+              <a:t>1,240 แต้ม · 2027-01-04</a:t>
+            </a:r>
+          </a:p>
+        </p:txBody>
+      </p:sp>
+      <p:cxnSp>
+        <p:nvCxnSpPr>
+          <p:cNvPr id="27" name="Connector 26"/>
+          <p:cNvCxnSpPr/>
+          <p:nvPr/>
+        </p:nvCxnSpPr>
+        <p:spPr>
+          <a:xfrm>
+            <a:off x="612648" y="5367527"/>
+            <a:ext cx="10966399" cy="0"/>
+          </a:xfrm>
+          <a:prstGeom prst="line">
+            <a:avLst/>
+          </a:prstGeom>
+          <a:ln w="9525">
+            <a:solidFill>
+              <a:srgbClr val="26262B"/>
+            </a:solidFill>
+          </a:ln>
+        </p:spPr>
+        <p:style>
+          <a:lnRef idx="2">
+            <a:schemeClr val="accent1"/>
+          </a:lnRef>
+          <a:fillRef idx="0">
+            <a:schemeClr val="accent1"/>
+          </a:fillRef>
+          <a:effectRef idx="1">
+            <a:schemeClr val="accent1"/>
+          </a:effectRef>
+          <a:fontRef idx="minor">
+            <a:schemeClr val="tx1"/>
+          </a:fontRef>
+        </p:style>
+      </p:cxnSp>
     </p:spTree>
   </p:cSld>
   <p:clrMapOvr>
@@ -26746,7 +28982,7 @@
                 <a:ea typeface="Chakra Petch"/>
                 <a:cs typeface="Chakra Petch"/>
               </a:rPr>
-              <a:t>04</a:t>
+              <a:t>4</a:t>
             </a:r>
           </a:p>
         </p:txBody>
@@ -27468,7 +29704,7 @@
                 <a:ea typeface="Chakra Petch"/>
                 <a:cs typeface="Chakra Petch"/>
               </a:rPr>
-              <a:t>05</a:t>
+              <a:t>5</a:t>
             </a:r>
           </a:p>
         </p:txBody>
@@ -28671,7 +30907,7 @@
                 <a:ea typeface="Chakra Petch"/>
                 <a:cs typeface="Chakra Petch"/>
               </a:rPr>
-              <a:t>06</a:t>
+              <a:t>6</a:t>
             </a:r>
           </a:p>
         </p:txBody>
@@ -29707,7 +31943,7 @@
                 <a:ea typeface="Chakra Petch"/>
                 <a:cs typeface="Chakra Petch"/>
               </a:rPr>
-              <a:t>07</a:t>
+              <a:t>7</a:t>
             </a:r>
           </a:p>
         </p:txBody>
@@ -31202,7 +33438,7 @@
                 <a:ea typeface="Chakra Petch"/>
                 <a:cs typeface="Chakra Petch"/>
               </a:rPr>
-              <a:t>08</a:t>
+              <a:t>8</a:t>
             </a:r>
           </a:p>
         </p:txBody>
@@ -31789,7 +34025,7 @@
                 <a:ea typeface="Chakra Petch"/>
                 <a:cs typeface="Chakra Petch"/>
               </a:rPr>
-              <a:t>09</a:t>
+              <a:t>9</a:t>
             </a:r>
           </a:p>
         </p:txBody>

</xml_diff>